<commit_message>
Agregar configuración de cámara, nombre del autor y animaciones
Co-Authored-By: Claude Sonnet 5.5 <noreply@anthropic.com>
Claude-Session: https://claude.ai/code/session_01Y5F8QoKRcD6in8KfcG1na8
</commit_message>
<xml_diff>
--- a/Ecosistemas_Digitales_Fotografias.pptx
+++ b/Ecosistemas_Digitales_Fotografias.pptx
@@ -3256,7 +3256,42 @@
       </p:sp>
       <p:sp>
         <p:nvSpPr>
-          <p:cNvPr id="6" name="Oval 5"/>
+          <p:cNvPr id="6" name="TextBox 5"/>
+          <p:cNvSpPr txBox="1"/>
+          <p:nvPr/>
+        </p:nvSpPr>
+        <p:spPr>
+          <a:xfrm>
+            <a:off x="1188720" y="4572000"/>
+            <a:ext cx="10058400" cy="548640"/>
+          </a:xfrm>
+          <a:prstGeom prst="rect">
+            <a:avLst/>
+          </a:prstGeom>
+          <a:noFill/>
+        </p:spPr>
+        <p:txBody>
+          <a:bodyPr wrap="square" anchor="t">
+            <a:spAutoFit/>
+          </a:bodyPr>
+          <a:lstStyle/>
+          <a:p>
+            <a:pPr algn="l"/>
+            <a:r>
+              <a:rPr sz="2000" b="1" i="0">
+                <a:solidFill>
+                  <a:srgbClr val="E0A030"/>
+                </a:solidFill>
+                <a:latin typeface="Calibri"/>
+              </a:rPr>
+              <a:t>Daniel Manzano</a:t>
+            </a:r>
+          </a:p>
+        </p:txBody>
+      </p:sp>
+      <p:sp>
+        <p:nvSpPr>
+          <p:cNvPr id="7" name="Oval 6"/>
           <p:cNvSpPr/>
           <p:nvPr/>
         </p:nvSpPr>
@@ -3299,7 +3334,7 @@
       </p:sp>
       <p:sp>
         <p:nvSpPr>
-          <p:cNvPr id="7" name="Oval 6"/>
+          <p:cNvPr id="8" name="Oval 7"/>
           <p:cNvSpPr/>
           <p:nvPr/>
         </p:nvSpPr>
@@ -3446,8 +3481,8 @@
         </p:nvSpPr>
         <p:spPr>
           <a:xfrm>
-            <a:off x="640080" y="5715000"/>
-            <a:ext cx="7132320" cy="365760"/>
+            <a:off x="640080" y="5669280"/>
+            <a:ext cx="7132320" cy="640080"/>
           </a:xfrm>
           <a:prstGeom prst="rect">
             <a:avLst/>
@@ -3468,14 +3503,14 @@
                 </a:solidFill>
                 <a:latin typeface="Calibri"/>
               </a:rPr>
-              <a:t>Configuración de cámara: ISO ___  ·  Apertura f/___  ·  Velocidad 1/___ s</a:t>
-            </a:r>
-          </a:p>
-        </p:txBody>
-      </p:sp>
-      <p:sp>
-        <p:nvSpPr>
-          <p:cNvPr id="5" name="TextBox 4"/>
+              <a:t>Configuración: ISO 200–400  ·  Velocidad 1/60 s  ·  Apertura según la luz (sombra)</a:t>
+            </a:r>
+          </a:p>
+        </p:txBody>
+      </p:sp>
+      <p:sp>
+        <p:nvSpPr>
+          <p:cNvPr id="8" name="TextBox 7"/>
           <p:cNvSpPr txBox="1"/>
           <p:nvPr/>
         </p:nvSpPr>
@@ -3510,7 +3545,7 @@
       </p:sp>
       <p:sp>
         <p:nvSpPr>
-          <p:cNvPr id="6" name="Rectangle 5"/>
+          <p:cNvPr id="9" name="Rectangle 8"/>
           <p:cNvSpPr/>
           <p:nvPr/>
         </p:nvSpPr>
@@ -3553,7 +3588,7 @@
       </p:sp>
       <p:sp>
         <p:nvSpPr>
-          <p:cNvPr id="7" name="TextBox 6"/>
+          <p:cNvPr id="10" name="TextBox 9"/>
           <p:cNvSpPr txBox="1"/>
           <p:nvPr/>
         </p:nvSpPr>
@@ -3588,7 +3623,7 @@
       </p:sp>
       <p:sp>
         <p:nvSpPr>
-          <p:cNvPr id="8" name="TextBox 7"/>
+          <p:cNvPr id="11" name="TextBox 10"/>
           <p:cNvSpPr txBox="1"/>
           <p:nvPr/>
         </p:nvSpPr>
@@ -3623,13 +3658,13 @@
       </p:sp>
       <p:sp>
         <p:nvSpPr>
-          <p:cNvPr id="9" name="TextBox 8"/>
+          <p:cNvPr id="12" name="TextBox 11"/>
           <p:cNvSpPr txBox="1"/>
           <p:nvPr/>
         </p:nvSpPr>
         <p:spPr>
           <a:xfrm>
-            <a:off x="8229600" y="6217920"/>
+            <a:off x="8229600" y="6172200"/>
             <a:ext cx="3566160" cy="365760"/>
           </a:xfrm>
           <a:prstGeom prst="rect">
@@ -3645,13 +3680,13 @@
           <a:p>
             <a:pPr algn="l"/>
             <a:r>
-              <a:rPr sz="1100" b="0" i="0">
+              <a:rPr sz="1400" b="1" i="0">
                 <a:solidFill>
                   <a:srgbClr val="2F4B4A"/>
                 </a:solidFill>
                 <a:latin typeface="Calibri"/>
               </a:rPr>
-              <a:t>Ecosistemas Digitales · Fotografías</a:t>
+              <a:t>Daniel Manzano</a:t>
             </a:r>
           </a:p>
         </p:txBody>
@@ -3661,6 +3696,95 @@
   <p:clrMapOvr>
     <a:masterClrMapping/>
   </p:clrMapOvr>
+  <p:transition spd="med">
+    <p:fade/>
+  </p:transition>
+  <p:timing>
+    <p:tnLst>
+      <p:par>
+        <p:cTn id="1" dur="indefinite" restart="never" nodeType="tmRoot">
+          <p:childTnLst>
+            <p:seq concurrent="1" nextAc="seek">
+              <p:cTn id="2" dur="indefinite" nodeType="mainSeq">
+                <p:childTnLst>
+                  <p:par>
+                    <p:cTn id="3" fill="hold">
+                      <p:stCondLst>
+                        <p:cond delay="indefinite"/>
+                        <p:cond evt="onBegin" delay="0">
+                          <p:tn val="2"/>
+                        </p:cond>
+                      </p:stCondLst>
+                      <p:childTnLst>
+                        <p:par>
+                          <p:cTn id="4" fill="hold">
+                            <p:stCondLst>
+                              <p:cond delay="0"/>
+                            </p:stCondLst>
+                            <p:childTnLst>
+                              <p:par>
+                                <p:cTn id="5" presetID="10" presetClass="entr" presetSubtype="0" fill="hold" nodeType="afterEffect">
+                                  <p:stCondLst>
+                                    <p:cond delay="0"/>
+                                  </p:stCondLst>
+                                  <p:childTnLst>
+                                    <p:set>
+                                      <p:cBhvr>
+                                        <p:cTn id="6" dur="1" fill="hold">
+                                          <p:stCondLst>
+                                            <p:cond delay="0"/>
+                                          </p:stCondLst>
+                                        </p:cTn>
+                                        <p:tgtEl>
+                                          <p:spTgt spid="3"/>
+                                        </p:tgtEl>
+                                        <p:attrNameLst>
+                                          <p:attrName>style.visibility</p:attrName>
+                                        </p:attrNameLst>
+                                      </p:cBhvr>
+                                      <p:to>
+                                        <p:strVal val="visible"/>
+                                      </p:to>
+                                    </p:set>
+                                    <p:animEffect transition="in" filter="fade">
+                                      <p:cBhvr>
+                                        <p:cTn id="7" dur="1200"/>
+                                        <p:tgtEl>
+                                          <p:spTgt spid="3"/>
+                                        </p:tgtEl>
+                                      </p:cBhvr>
+                                    </p:animEffect>
+                                  </p:childTnLst>
+                                </p:cTn>
+                              </p:par>
+                            </p:childTnLst>
+                          </p:cTn>
+                        </p:par>
+                      </p:childTnLst>
+                    </p:cTn>
+                  </p:par>
+                </p:childTnLst>
+              </p:cTn>
+              <p:prevCondLst>
+                <p:cond evt="onPrev" delay="0">
+                  <p:tgtEl>
+                    <p:sldTgt/>
+                  </p:tgtEl>
+                </p:cond>
+              </p:prevCondLst>
+              <p:nextCondLst>
+                <p:cond evt="onNext" delay="0">
+                  <p:tgtEl>
+                    <p:sldTgt/>
+                  </p:tgtEl>
+                </p:cond>
+              </p:nextCondLst>
+            </p:seq>
+          </p:childTnLst>
+        </p:cTn>
+      </p:par>
+    </p:tnLst>
+  </p:timing>
 </p:sld>
 </file>
 
@@ -3762,8 +3886,8 @@
         </p:nvSpPr>
         <p:spPr>
           <a:xfrm>
-            <a:off x="640080" y="5715000"/>
-            <a:ext cx="7132320" cy="365760"/>
+            <a:off x="640080" y="5669280"/>
+            <a:ext cx="7132320" cy="640080"/>
           </a:xfrm>
           <a:prstGeom prst="rect">
             <a:avLst/>
@@ -3784,14 +3908,14 @@
                 </a:solidFill>
                 <a:latin typeface="Calibri"/>
               </a:rPr>
-              <a:t>Configuración de cámara: ISO ___  ·  Apertura f/___  ·  Velocidad 1/___ s</a:t>
-            </a:r>
-          </a:p>
-        </p:txBody>
-      </p:sp>
-      <p:sp>
-        <p:nvSpPr>
-          <p:cNvPr id="5" name="TextBox 4"/>
+              <a:t>Configuración: ISO 200–400  ·  Velocidad 1/60 s  ·  Apertura según la luz (luz de sol)</a:t>
+            </a:r>
+          </a:p>
+        </p:txBody>
+      </p:sp>
+      <p:sp>
+        <p:nvSpPr>
+          <p:cNvPr id="8" name="TextBox 7"/>
           <p:cNvSpPr txBox="1"/>
           <p:nvPr/>
         </p:nvSpPr>
@@ -3826,7 +3950,7 @@
       </p:sp>
       <p:sp>
         <p:nvSpPr>
-          <p:cNvPr id="6" name="Rectangle 5"/>
+          <p:cNvPr id="9" name="Rectangle 8"/>
           <p:cNvSpPr/>
           <p:nvPr/>
         </p:nvSpPr>
@@ -3869,7 +3993,7 @@
       </p:sp>
       <p:sp>
         <p:nvSpPr>
-          <p:cNvPr id="7" name="TextBox 6"/>
+          <p:cNvPr id="10" name="TextBox 9"/>
           <p:cNvSpPr txBox="1"/>
           <p:nvPr/>
         </p:nvSpPr>
@@ -3904,7 +4028,7 @@
       </p:sp>
       <p:sp>
         <p:nvSpPr>
-          <p:cNvPr id="8" name="TextBox 7"/>
+          <p:cNvPr id="11" name="TextBox 10"/>
           <p:cNvSpPr txBox="1"/>
           <p:nvPr/>
         </p:nvSpPr>
@@ -3939,13 +4063,13 @@
       </p:sp>
       <p:sp>
         <p:nvSpPr>
-          <p:cNvPr id="9" name="TextBox 8"/>
+          <p:cNvPr id="12" name="TextBox 11"/>
           <p:cNvSpPr txBox="1"/>
           <p:nvPr/>
         </p:nvSpPr>
         <p:spPr>
           <a:xfrm>
-            <a:off x="8229600" y="6217920"/>
+            <a:off x="8229600" y="6172200"/>
             <a:ext cx="3566160" cy="365760"/>
           </a:xfrm>
           <a:prstGeom prst="rect">
@@ -3961,13 +4085,13 @@
           <a:p>
             <a:pPr algn="l"/>
             <a:r>
-              <a:rPr sz="1100" b="0" i="0">
+              <a:rPr sz="1400" b="1" i="0">
                 <a:solidFill>
                   <a:srgbClr val="2F4B4A"/>
                 </a:solidFill>
                 <a:latin typeface="Calibri"/>
               </a:rPr>
-              <a:t>Ecosistemas Digitales · Fotografías</a:t>
+              <a:t>Daniel Manzano</a:t>
             </a:r>
           </a:p>
         </p:txBody>
@@ -3977,6 +4101,95 @@
   <p:clrMapOvr>
     <a:masterClrMapping/>
   </p:clrMapOvr>
+  <p:transition spd="med">
+    <p:fade/>
+  </p:transition>
+  <p:timing>
+    <p:tnLst>
+      <p:par>
+        <p:cTn id="1" dur="indefinite" restart="never" nodeType="tmRoot">
+          <p:childTnLst>
+            <p:seq concurrent="1" nextAc="seek">
+              <p:cTn id="2" dur="indefinite" nodeType="mainSeq">
+                <p:childTnLst>
+                  <p:par>
+                    <p:cTn id="3" fill="hold">
+                      <p:stCondLst>
+                        <p:cond delay="indefinite"/>
+                        <p:cond evt="onBegin" delay="0">
+                          <p:tn val="2"/>
+                        </p:cond>
+                      </p:stCondLst>
+                      <p:childTnLst>
+                        <p:par>
+                          <p:cTn id="4" fill="hold">
+                            <p:stCondLst>
+                              <p:cond delay="0"/>
+                            </p:stCondLst>
+                            <p:childTnLst>
+                              <p:par>
+                                <p:cTn id="5" presetID="10" presetClass="entr" presetSubtype="0" fill="hold" nodeType="afterEffect">
+                                  <p:stCondLst>
+                                    <p:cond delay="0"/>
+                                  </p:stCondLst>
+                                  <p:childTnLst>
+                                    <p:set>
+                                      <p:cBhvr>
+                                        <p:cTn id="6" dur="1" fill="hold">
+                                          <p:stCondLst>
+                                            <p:cond delay="0"/>
+                                          </p:stCondLst>
+                                        </p:cTn>
+                                        <p:tgtEl>
+                                          <p:spTgt spid="3"/>
+                                        </p:tgtEl>
+                                        <p:attrNameLst>
+                                          <p:attrName>style.visibility</p:attrName>
+                                        </p:attrNameLst>
+                                      </p:cBhvr>
+                                      <p:to>
+                                        <p:strVal val="visible"/>
+                                      </p:to>
+                                    </p:set>
+                                    <p:animEffect transition="in" filter="fade">
+                                      <p:cBhvr>
+                                        <p:cTn id="7" dur="1200"/>
+                                        <p:tgtEl>
+                                          <p:spTgt spid="3"/>
+                                        </p:tgtEl>
+                                      </p:cBhvr>
+                                    </p:animEffect>
+                                  </p:childTnLst>
+                                </p:cTn>
+                              </p:par>
+                            </p:childTnLst>
+                          </p:cTn>
+                        </p:par>
+                      </p:childTnLst>
+                    </p:cTn>
+                  </p:par>
+                </p:childTnLst>
+              </p:cTn>
+              <p:prevCondLst>
+                <p:cond evt="onPrev" delay="0">
+                  <p:tgtEl>
+                    <p:sldTgt/>
+                  </p:tgtEl>
+                </p:cond>
+              </p:prevCondLst>
+              <p:nextCondLst>
+                <p:cond evt="onNext" delay="0">
+                  <p:tgtEl>
+                    <p:sldTgt/>
+                  </p:tgtEl>
+                </p:cond>
+              </p:nextCondLst>
+            </p:seq>
+          </p:childTnLst>
+        </p:cTn>
+      </p:par>
+    </p:tnLst>
+  </p:timing>
 </p:sld>
 </file>
 
@@ -4078,8 +4291,8 @@
         </p:nvSpPr>
         <p:spPr>
           <a:xfrm>
-            <a:off x="640080" y="5715000"/>
-            <a:ext cx="7132320" cy="365760"/>
+            <a:off x="640080" y="5669280"/>
+            <a:ext cx="7132320" cy="640080"/>
           </a:xfrm>
           <a:prstGeom prst="rect">
             <a:avLst/>
@@ -4100,14 +4313,14 @@
                 </a:solidFill>
                 <a:latin typeface="Calibri"/>
               </a:rPr>
-              <a:t>Configuración de cámara: ISO ___  ·  Apertura f/___  ·  Velocidad 1/___ s</a:t>
-            </a:r>
-          </a:p>
-        </p:txBody>
-      </p:sp>
-      <p:sp>
-        <p:nvSpPr>
-          <p:cNvPr id="5" name="TextBox 4"/>
+              <a:t>Configuración: ISO 200–400  ·  Velocidad 1/60 s  ·  Apertura según la luz (luz de sol)</a:t>
+            </a:r>
+          </a:p>
+        </p:txBody>
+      </p:sp>
+      <p:sp>
+        <p:nvSpPr>
+          <p:cNvPr id="8" name="TextBox 7"/>
           <p:cNvSpPr txBox="1"/>
           <p:nvPr/>
         </p:nvSpPr>
@@ -4142,7 +4355,7 @@
       </p:sp>
       <p:sp>
         <p:nvSpPr>
-          <p:cNvPr id="6" name="Rectangle 5"/>
+          <p:cNvPr id="9" name="Rectangle 8"/>
           <p:cNvSpPr/>
           <p:nvPr/>
         </p:nvSpPr>
@@ -4185,7 +4398,7 @@
       </p:sp>
       <p:sp>
         <p:nvSpPr>
-          <p:cNvPr id="7" name="TextBox 6"/>
+          <p:cNvPr id="10" name="TextBox 9"/>
           <p:cNvSpPr txBox="1"/>
           <p:nvPr/>
         </p:nvSpPr>
@@ -4220,7 +4433,7 @@
       </p:sp>
       <p:sp>
         <p:nvSpPr>
-          <p:cNvPr id="8" name="TextBox 7"/>
+          <p:cNvPr id="11" name="TextBox 10"/>
           <p:cNvSpPr txBox="1"/>
           <p:nvPr/>
         </p:nvSpPr>
@@ -4255,13 +4468,13 @@
       </p:sp>
       <p:sp>
         <p:nvSpPr>
-          <p:cNvPr id="9" name="TextBox 8"/>
+          <p:cNvPr id="12" name="TextBox 11"/>
           <p:cNvSpPr txBox="1"/>
           <p:nvPr/>
         </p:nvSpPr>
         <p:spPr>
           <a:xfrm>
-            <a:off x="8229600" y="6217920"/>
+            <a:off x="8229600" y="6172200"/>
             <a:ext cx="3566160" cy="365760"/>
           </a:xfrm>
           <a:prstGeom prst="rect">
@@ -4277,13 +4490,13 @@
           <a:p>
             <a:pPr algn="l"/>
             <a:r>
-              <a:rPr sz="1100" b="0" i="0">
+              <a:rPr sz="1400" b="1" i="0">
                 <a:solidFill>
                   <a:srgbClr val="2F4B4A"/>
                 </a:solidFill>
                 <a:latin typeface="Calibri"/>
               </a:rPr>
-              <a:t>Ecosistemas Digitales · Fotografías</a:t>
+              <a:t>Daniel Manzano</a:t>
             </a:r>
           </a:p>
         </p:txBody>
@@ -4293,6 +4506,95 @@
   <p:clrMapOvr>
     <a:masterClrMapping/>
   </p:clrMapOvr>
+  <p:transition spd="med">
+    <p:fade/>
+  </p:transition>
+  <p:timing>
+    <p:tnLst>
+      <p:par>
+        <p:cTn id="1" dur="indefinite" restart="never" nodeType="tmRoot">
+          <p:childTnLst>
+            <p:seq concurrent="1" nextAc="seek">
+              <p:cTn id="2" dur="indefinite" nodeType="mainSeq">
+                <p:childTnLst>
+                  <p:par>
+                    <p:cTn id="3" fill="hold">
+                      <p:stCondLst>
+                        <p:cond delay="indefinite"/>
+                        <p:cond evt="onBegin" delay="0">
+                          <p:tn val="2"/>
+                        </p:cond>
+                      </p:stCondLst>
+                      <p:childTnLst>
+                        <p:par>
+                          <p:cTn id="4" fill="hold">
+                            <p:stCondLst>
+                              <p:cond delay="0"/>
+                            </p:stCondLst>
+                            <p:childTnLst>
+                              <p:par>
+                                <p:cTn id="5" presetID="10" presetClass="entr" presetSubtype="0" fill="hold" nodeType="afterEffect">
+                                  <p:stCondLst>
+                                    <p:cond delay="0"/>
+                                  </p:stCondLst>
+                                  <p:childTnLst>
+                                    <p:set>
+                                      <p:cBhvr>
+                                        <p:cTn id="6" dur="1" fill="hold">
+                                          <p:stCondLst>
+                                            <p:cond delay="0"/>
+                                          </p:stCondLst>
+                                        </p:cTn>
+                                        <p:tgtEl>
+                                          <p:spTgt spid="3"/>
+                                        </p:tgtEl>
+                                        <p:attrNameLst>
+                                          <p:attrName>style.visibility</p:attrName>
+                                        </p:attrNameLst>
+                                      </p:cBhvr>
+                                      <p:to>
+                                        <p:strVal val="visible"/>
+                                      </p:to>
+                                    </p:set>
+                                    <p:animEffect transition="in" filter="fade">
+                                      <p:cBhvr>
+                                        <p:cTn id="7" dur="1200"/>
+                                        <p:tgtEl>
+                                          <p:spTgt spid="3"/>
+                                        </p:tgtEl>
+                                      </p:cBhvr>
+                                    </p:animEffect>
+                                  </p:childTnLst>
+                                </p:cTn>
+                              </p:par>
+                            </p:childTnLst>
+                          </p:cTn>
+                        </p:par>
+                      </p:childTnLst>
+                    </p:cTn>
+                  </p:par>
+                </p:childTnLst>
+              </p:cTn>
+              <p:prevCondLst>
+                <p:cond evt="onPrev" delay="0">
+                  <p:tgtEl>
+                    <p:sldTgt/>
+                  </p:tgtEl>
+                </p:cond>
+              </p:prevCondLst>
+              <p:nextCondLst>
+                <p:cond evt="onNext" delay="0">
+                  <p:tgtEl>
+                    <p:sldTgt/>
+                  </p:tgtEl>
+                </p:cond>
+              </p:nextCondLst>
+            </p:seq>
+          </p:childTnLst>
+        </p:cTn>
+      </p:par>
+    </p:tnLst>
+  </p:timing>
 </p:sld>
 </file>
 
@@ -4394,8 +4696,8 @@
         </p:nvSpPr>
         <p:spPr>
           <a:xfrm>
-            <a:off x="640080" y="5715000"/>
-            <a:ext cx="7132320" cy="365760"/>
+            <a:off x="640080" y="5669280"/>
+            <a:ext cx="7132320" cy="640080"/>
           </a:xfrm>
           <a:prstGeom prst="rect">
             <a:avLst/>
@@ -4416,14 +4718,14 @@
                 </a:solidFill>
                 <a:latin typeface="Calibri"/>
               </a:rPr>
-              <a:t>Configuración de cámara: ISO ___  ·  Apertura f/___  ·  Velocidad 1/___ s</a:t>
-            </a:r>
-          </a:p>
-        </p:txBody>
-      </p:sp>
-      <p:sp>
-        <p:nvSpPr>
-          <p:cNvPr id="5" name="TextBox 4"/>
+              <a:t>Configuración: ISO 200–400  ·  Velocidad 1/60 s  ·  Apertura según la luz (luz de sol)</a:t>
+            </a:r>
+          </a:p>
+        </p:txBody>
+      </p:sp>
+      <p:sp>
+        <p:nvSpPr>
+          <p:cNvPr id="8" name="TextBox 7"/>
           <p:cNvSpPr txBox="1"/>
           <p:nvPr/>
         </p:nvSpPr>
@@ -4458,7 +4760,7 @@
       </p:sp>
       <p:sp>
         <p:nvSpPr>
-          <p:cNvPr id="6" name="Rectangle 5"/>
+          <p:cNvPr id="9" name="Rectangle 8"/>
           <p:cNvSpPr/>
           <p:nvPr/>
         </p:nvSpPr>
@@ -4501,7 +4803,7 @@
       </p:sp>
       <p:sp>
         <p:nvSpPr>
-          <p:cNvPr id="7" name="TextBox 6"/>
+          <p:cNvPr id="10" name="TextBox 9"/>
           <p:cNvSpPr txBox="1"/>
           <p:nvPr/>
         </p:nvSpPr>
@@ -4536,7 +4838,7 @@
       </p:sp>
       <p:sp>
         <p:nvSpPr>
-          <p:cNvPr id="8" name="TextBox 7"/>
+          <p:cNvPr id="11" name="TextBox 10"/>
           <p:cNvSpPr txBox="1"/>
           <p:nvPr/>
         </p:nvSpPr>
@@ -4571,13 +4873,13 @@
       </p:sp>
       <p:sp>
         <p:nvSpPr>
-          <p:cNvPr id="9" name="TextBox 8"/>
+          <p:cNvPr id="12" name="TextBox 11"/>
           <p:cNvSpPr txBox="1"/>
           <p:nvPr/>
         </p:nvSpPr>
         <p:spPr>
           <a:xfrm>
-            <a:off x="8229600" y="6217920"/>
+            <a:off x="8229600" y="6172200"/>
             <a:ext cx="3566160" cy="365760"/>
           </a:xfrm>
           <a:prstGeom prst="rect">
@@ -4593,13 +4895,13 @@
           <a:p>
             <a:pPr algn="l"/>
             <a:r>
-              <a:rPr sz="1100" b="0" i="0">
+              <a:rPr sz="1400" b="1" i="0">
                 <a:solidFill>
                   <a:srgbClr val="2F4B4A"/>
                 </a:solidFill>
                 <a:latin typeface="Calibri"/>
               </a:rPr>
-              <a:t>Ecosistemas Digitales · Fotografías</a:t>
+              <a:t>Daniel Manzano</a:t>
             </a:r>
           </a:p>
         </p:txBody>
@@ -4609,6 +4911,95 @@
   <p:clrMapOvr>
     <a:masterClrMapping/>
   </p:clrMapOvr>
+  <p:transition spd="med">
+    <p:fade/>
+  </p:transition>
+  <p:timing>
+    <p:tnLst>
+      <p:par>
+        <p:cTn id="1" dur="indefinite" restart="never" nodeType="tmRoot">
+          <p:childTnLst>
+            <p:seq concurrent="1" nextAc="seek">
+              <p:cTn id="2" dur="indefinite" nodeType="mainSeq">
+                <p:childTnLst>
+                  <p:par>
+                    <p:cTn id="3" fill="hold">
+                      <p:stCondLst>
+                        <p:cond delay="indefinite"/>
+                        <p:cond evt="onBegin" delay="0">
+                          <p:tn val="2"/>
+                        </p:cond>
+                      </p:stCondLst>
+                      <p:childTnLst>
+                        <p:par>
+                          <p:cTn id="4" fill="hold">
+                            <p:stCondLst>
+                              <p:cond delay="0"/>
+                            </p:stCondLst>
+                            <p:childTnLst>
+                              <p:par>
+                                <p:cTn id="5" presetID="10" presetClass="entr" presetSubtype="0" fill="hold" nodeType="afterEffect">
+                                  <p:stCondLst>
+                                    <p:cond delay="0"/>
+                                  </p:stCondLst>
+                                  <p:childTnLst>
+                                    <p:set>
+                                      <p:cBhvr>
+                                        <p:cTn id="6" dur="1" fill="hold">
+                                          <p:stCondLst>
+                                            <p:cond delay="0"/>
+                                          </p:stCondLst>
+                                        </p:cTn>
+                                        <p:tgtEl>
+                                          <p:spTgt spid="3"/>
+                                        </p:tgtEl>
+                                        <p:attrNameLst>
+                                          <p:attrName>style.visibility</p:attrName>
+                                        </p:attrNameLst>
+                                      </p:cBhvr>
+                                      <p:to>
+                                        <p:strVal val="visible"/>
+                                      </p:to>
+                                    </p:set>
+                                    <p:animEffect transition="in" filter="fade">
+                                      <p:cBhvr>
+                                        <p:cTn id="7" dur="1200"/>
+                                        <p:tgtEl>
+                                          <p:spTgt spid="3"/>
+                                        </p:tgtEl>
+                                      </p:cBhvr>
+                                    </p:animEffect>
+                                  </p:childTnLst>
+                                </p:cTn>
+                              </p:par>
+                            </p:childTnLst>
+                          </p:cTn>
+                        </p:par>
+                      </p:childTnLst>
+                    </p:cTn>
+                  </p:par>
+                </p:childTnLst>
+              </p:cTn>
+              <p:prevCondLst>
+                <p:cond evt="onPrev" delay="0">
+                  <p:tgtEl>
+                    <p:sldTgt/>
+                  </p:tgtEl>
+                </p:cond>
+              </p:prevCondLst>
+              <p:nextCondLst>
+                <p:cond evt="onNext" delay="0">
+                  <p:tgtEl>
+                    <p:sldTgt/>
+                  </p:tgtEl>
+                </p:cond>
+              </p:nextCondLst>
+            </p:seq>
+          </p:childTnLst>
+        </p:cTn>
+      </p:par>
+    </p:tnLst>
+  </p:timing>
 </p:sld>
 </file>
 
@@ -4710,8 +5101,8 @@
         </p:nvSpPr>
         <p:spPr>
           <a:xfrm>
-            <a:off x="640080" y="5715000"/>
-            <a:ext cx="7132320" cy="365760"/>
+            <a:off x="640080" y="5669280"/>
+            <a:ext cx="7132320" cy="640080"/>
           </a:xfrm>
           <a:prstGeom prst="rect">
             <a:avLst/>
@@ -4732,14 +5123,14 @@
                 </a:solidFill>
                 <a:latin typeface="Calibri"/>
               </a:rPr>
-              <a:t>Configuración de cámara: ISO ___  ·  Apertura f/___  ·  Velocidad 1/___ s</a:t>
-            </a:r>
-          </a:p>
-        </p:txBody>
-      </p:sp>
-      <p:sp>
-        <p:nvSpPr>
-          <p:cNvPr id="5" name="TextBox 4"/>
+              <a:t>Configuración: ISO 200–400  ·  Velocidad 1/60 s  ·  Apertura según la luz (luz de sol)</a:t>
+            </a:r>
+          </a:p>
+        </p:txBody>
+      </p:sp>
+      <p:sp>
+        <p:nvSpPr>
+          <p:cNvPr id="8" name="TextBox 7"/>
           <p:cNvSpPr txBox="1"/>
           <p:nvPr/>
         </p:nvSpPr>
@@ -4774,7 +5165,7 @@
       </p:sp>
       <p:sp>
         <p:nvSpPr>
-          <p:cNvPr id="6" name="Rectangle 5"/>
+          <p:cNvPr id="9" name="Rectangle 8"/>
           <p:cNvSpPr/>
           <p:nvPr/>
         </p:nvSpPr>
@@ -4817,7 +5208,7 @@
       </p:sp>
       <p:sp>
         <p:nvSpPr>
-          <p:cNvPr id="7" name="TextBox 6"/>
+          <p:cNvPr id="10" name="TextBox 9"/>
           <p:cNvSpPr txBox="1"/>
           <p:nvPr/>
         </p:nvSpPr>
@@ -4852,7 +5243,7 @@
       </p:sp>
       <p:sp>
         <p:nvSpPr>
-          <p:cNvPr id="8" name="TextBox 7"/>
+          <p:cNvPr id="11" name="TextBox 10"/>
           <p:cNvSpPr txBox="1"/>
           <p:nvPr/>
         </p:nvSpPr>
@@ -4887,13 +5278,13 @@
       </p:sp>
       <p:sp>
         <p:nvSpPr>
-          <p:cNvPr id="9" name="TextBox 8"/>
+          <p:cNvPr id="12" name="TextBox 11"/>
           <p:cNvSpPr txBox="1"/>
           <p:nvPr/>
         </p:nvSpPr>
         <p:spPr>
           <a:xfrm>
-            <a:off x="8229600" y="6217920"/>
+            <a:off x="8229600" y="6172200"/>
             <a:ext cx="3566160" cy="365760"/>
           </a:xfrm>
           <a:prstGeom prst="rect">
@@ -4909,13 +5300,13 @@
           <a:p>
             <a:pPr algn="l"/>
             <a:r>
-              <a:rPr sz="1100" b="0" i="0">
+              <a:rPr sz="1400" b="1" i="0">
                 <a:solidFill>
                   <a:srgbClr val="2F4B4A"/>
                 </a:solidFill>
                 <a:latin typeface="Calibri"/>
               </a:rPr>
-              <a:t>Ecosistemas Digitales · Fotografías</a:t>
+              <a:t>Daniel Manzano</a:t>
             </a:r>
           </a:p>
         </p:txBody>
@@ -4925,6 +5316,95 @@
   <p:clrMapOvr>
     <a:masterClrMapping/>
   </p:clrMapOvr>
+  <p:transition spd="med">
+    <p:fade/>
+  </p:transition>
+  <p:timing>
+    <p:tnLst>
+      <p:par>
+        <p:cTn id="1" dur="indefinite" restart="never" nodeType="tmRoot">
+          <p:childTnLst>
+            <p:seq concurrent="1" nextAc="seek">
+              <p:cTn id="2" dur="indefinite" nodeType="mainSeq">
+                <p:childTnLst>
+                  <p:par>
+                    <p:cTn id="3" fill="hold">
+                      <p:stCondLst>
+                        <p:cond delay="indefinite"/>
+                        <p:cond evt="onBegin" delay="0">
+                          <p:tn val="2"/>
+                        </p:cond>
+                      </p:stCondLst>
+                      <p:childTnLst>
+                        <p:par>
+                          <p:cTn id="4" fill="hold">
+                            <p:stCondLst>
+                              <p:cond delay="0"/>
+                            </p:stCondLst>
+                            <p:childTnLst>
+                              <p:par>
+                                <p:cTn id="5" presetID="10" presetClass="entr" presetSubtype="0" fill="hold" nodeType="afterEffect">
+                                  <p:stCondLst>
+                                    <p:cond delay="0"/>
+                                  </p:stCondLst>
+                                  <p:childTnLst>
+                                    <p:set>
+                                      <p:cBhvr>
+                                        <p:cTn id="6" dur="1" fill="hold">
+                                          <p:stCondLst>
+                                            <p:cond delay="0"/>
+                                          </p:stCondLst>
+                                        </p:cTn>
+                                        <p:tgtEl>
+                                          <p:spTgt spid="3"/>
+                                        </p:tgtEl>
+                                        <p:attrNameLst>
+                                          <p:attrName>style.visibility</p:attrName>
+                                        </p:attrNameLst>
+                                      </p:cBhvr>
+                                      <p:to>
+                                        <p:strVal val="visible"/>
+                                      </p:to>
+                                    </p:set>
+                                    <p:animEffect transition="in" filter="fade">
+                                      <p:cBhvr>
+                                        <p:cTn id="7" dur="1200"/>
+                                        <p:tgtEl>
+                                          <p:spTgt spid="3"/>
+                                        </p:tgtEl>
+                                      </p:cBhvr>
+                                    </p:animEffect>
+                                  </p:childTnLst>
+                                </p:cTn>
+                              </p:par>
+                            </p:childTnLst>
+                          </p:cTn>
+                        </p:par>
+                      </p:childTnLst>
+                    </p:cTn>
+                  </p:par>
+                </p:childTnLst>
+              </p:cTn>
+              <p:prevCondLst>
+                <p:cond evt="onPrev" delay="0">
+                  <p:tgtEl>
+                    <p:sldTgt/>
+                  </p:tgtEl>
+                </p:cond>
+              </p:prevCondLst>
+              <p:nextCondLst>
+                <p:cond evt="onNext" delay="0">
+                  <p:tgtEl>
+                    <p:sldTgt/>
+                  </p:tgtEl>
+                </p:cond>
+              </p:nextCondLst>
+            </p:seq>
+          </p:childTnLst>
+        </p:cTn>
+      </p:par>
+    </p:tnLst>
+  </p:timing>
 </p:sld>
 </file>
 
@@ -5026,8 +5506,8 @@
         </p:nvSpPr>
         <p:spPr>
           <a:xfrm>
-            <a:off x="640080" y="5715000"/>
-            <a:ext cx="7132320" cy="365760"/>
+            <a:off x="640080" y="5669280"/>
+            <a:ext cx="7132320" cy="640080"/>
           </a:xfrm>
           <a:prstGeom prst="rect">
             <a:avLst/>
@@ -5048,14 +5528,14 @@
                 </a:solidFill>
                 <a:latin typeface="Calibri"/>
               </a:rPr>
-              <a:t>Configuración de cámara: ISO ___  ·  Apertura f/___  ·  Velocidad 1/___ s</a:t>
-            </a:r>
-          </a:p>
-        </p:txBody>
-      </p:sp>
-      <p:sp>
-        <p:nvSpPr>
-          <p:cNvPr id="5" name="TextBox 4"/>
+              <a:t>Configuración: ISO 200–400  ·  Velocidad 1/60 s  ·  Apertura según la luz (luz suave de pasillo)</a:t>
+            </a:r>
+          </a:p>
+        </p:txBody>
+      </p:sp>
+      <p:sp>
+        <p:nvSpPr>
+          <p:cNvPr id="8" name="TextBox 7"/>
           <p:cNvSpPr txBox="1"/>
           <p:nvPr/>
         </p:nvSpPr>
@@ -5090,7 +5570,7 @@
       </p:sp>
       <p:sp>
         <p:nvSpPr>
-          <p:cNvPr id="6" name="Rectangle 5"/>
+          <p:cNvPr id="9" name="Rectangle 8"/>
           <p:cNvSpPr/>
           <p:nvPr/>
         </p:nvSpPr>
@@ -5133,7 +5613,7 @@
       </p:sp>
       <p:sp>
         <p:nvSpPr>
-          <p:cNvPr id="7" name="TextBox 6"/>
+          <p:cNvPr id="10" name="TextBox 9"/>
           <p:cNvSpPr txBox="1"/>
           <p:nvPr/>
         </p:nvSpPr>
@@ -5168,7 +5648,7 @@
       </p:sp>
       <p:sp>
         <p:nvSpPr>
-          <p:cNvPr id="8" name="TextBox 7"/>
+          <p:cNvPr id="11" name="TextBox 10"/>
           <p:cNvSpPr txBox="1"/>
           <p:nvPr/>
         </p:nvSpPr>
@@ -5203,13 +5683,13 @@
       </p:sp>
       <p:sp>
         <p:nvSpPr>
-          <p:cNvPr id="9" name="TextBox 8"/>
+          <p:cNvPr id="12" name="TextBox 11"/>
           <p:cNvSpPr txBox="1"/>
           <p:nvPr/>
         </p:nvSpPr>
         <p:spPr>
           <a:xfrm>
-            <a:off x="8229600" y="6217920"/>
+            <a:off x="8229600" y="6172200"/>
             <a:ext cx="3566160" cy="365760"/>
           </a:xfrm>
           <a:prstGeom prst="rect">
@@ -5225,13 +5705,13 @@
           <a:p>
             <a:pPr algn="l"/>
             <a:r>
-              <a:rPr sz="1100" b="0" i="0">
+              <a:rPr sz="1400" b="1" i="0">
                 <a:solidFill>
                   <a:srgbClr val="2F4B4A"/>
                 </a:solidFill>
                 <a:latin typeface="Calibri"/>
               </a:rPr>
-              <a:t>Ecosistemas Digitales · Fotografías</a:t>
+              <a:t>Daniel Manzano</a:t>
             </a:r>
           </a:p>
         </p:txBody>
@@ -5241,6 +5721,95 @@
   <p:clrMapOvr>
     <a:masterClrMapping/>
   </p:clrMapOvr>
+  <p:transition spd="med">
+    <p:fade/>
+  </p:transition>
+  <p:timing>
+    <p:tnLst>
+      <p:par>
+        <p:cTn id="1" dur="indefinite" restart="never" nodeType="tmRoot">
+          <p:childTnLst>
+            <p:seq concurrent="1" nextAc="seek">
+              <p:cTn id="2" dur="indefinite" nodeType="mainSeq">
+                <p:childTnLst>
+                  <p:par>
+                    <p:cTn id="3" fill="hold">
+                      <p:stCondLst>
+                        <p:cond delay="indefinite"/>
+                        <p:cond evt="onBegin" delay="0">
+                          <p:tn val="2"/>
+                        </p:cond>
+                      </p:stCondLst>
+                      <p:childTnLst>
+                        <p:par>
+                          <p:cTn id="4" fill="hold">
+                            <p:stCondLst>
+                              <p:cond delay="0"/>
+                            </p:stCondLst>
+                            <p:childTnLst>
+                              <p:par>
+                                <p:cTn id="5" presetID="10" presetClass="entr" presetSubtype="0" fill="hold" nodeType="afterEffect">
+                                  <p:stCondLst>
+                                    <p:cond delay="0"/>
+                                  </p:stCondLst>
+                                  <p:childTnLst>
+                                    <p:set>
+                                      <p:cBhvr>
+                                        <p:cTn id="6" dur="1" fill="hold">
+                                          <p:stCondLst>
+                                            <p:cond delay="0"/>
+                                          </p:stCondLst>
+                                        </p:cTn>
+                                        <p:tgtEl>
+                                          <p:spTgt spid="3"/>
+                                        </p:tgtEl>
+                                        <p:attrNameLst>
+                                          <p:attrName>style.visibility</p:attrName>
+                                        </p:attrNameLst>
+                                      </p:cBhvr>
+                                      <p:to>
+                                        <p:strVal val="visible"/>
+                                      </p:to>
+                                    </p:set>
+                                    <p:animEffect transition="in" filter="fade">
+                                      <p:cBhvr>
+                                        <p:cTn id="7" dur="1200"/>
+                                        <p:tgtEl>
+                                          <p:spTgt spid="3"/>
+                                        </p:tgtEl>
+                                      </p:cBhvr>
+                                    </p:animEffect>
+                                  </p:childTnLst>
+                                </p:cTn>
+                              </p:par>
+                            </p:childTnLst>
+                          </p:cTn>
+                        </p:par>
+                      </p:childTnLst>
+                    </p:cTn>
+                  </p:par>
+                </p:childTnLst>
+              </p:cTn>
+              <p:prevCondLst>
+                <p:cond evt="onPrev" delay="0">
+                  <p:tgtEl>
+                    <p:sldTgt/>
+                  </p:tgtEl>
+                </p:cond>
+              </p:prevCondLst>
+              <p:nextCondLst>
+                <p:cond evt="onNext" delay="0">
+                  <p:tgtEl>
+                    <p:sldTgt/>
+                  </p:tgtEl>
+                </p:cond>
+              </p:nextCondLst>
+            </p:seq>
+          </p:childTnLst>
+        </p:cTn>
+      </p:par>
+    </p:tnLst>
+  </p:timing>
 </p:sld>
 </file>
 
@@ -5342,8 +5911,8 @@
         </p:nvSpPr>
         <p:spPr>
           <a:xfrm>
-            <a:off x="640080" y="5715000"/>
-            <a:ext cx="7132320" cy="365760"/>
+            <a:off x="640080" y="5669280"/>
+            <a:ext cx="7132320" cy="640080"/>
           </a:xfrm>
           <a:prstGeom prst="rect">
             <a:avLst/>
@@ -5364,14 +5933,14 @@
                 </a:solidFill>
                 <a:latin typeface="Calibri"/>
               </a:rPr>
-              <a:t>Configuración de cámara: ISO ___  ·  Apertura f/___  ·  Velocidad 1/___ s</a:t>
-            </a:r>
-          </a:p>
-        </p:txBody>
-      </p:sp>
-      <p:sp>
-        <p:nvSpPr>
-          <p:cNvPr id="5" name="TextBox 4"/>
+              <a:t>Configuración: ISO 200–400  ·  Velocidad 1/60 s  ·  Apertura según la luz (luz de sol)</a:t>
+            </a:r>
+          </a:p>
+        </p:txBody>
+      </p:sp>
+      <p:sp>
+        <p:nvSpPr>
+          <p:cNvPr id="8" name="TextBox 7"/>
           <p:cNvSpPr txBox="1"/>
           <p:nvPr/>
         </p:nvSpPr>
@@ -5406,7 +5975,7 @@
       </p:sp>
       <p:sp>
         <p:nvSpPr>
-          <p:cNvPr id="6" name="Rectangle 5"/>
+          <p:cNvPr id="9" name="Rectangle 8"/>
           <p:cNvSpPr/>
           <p:nvPr/>
         </p:nvSpPr>
@@ -5449,7 +6018,7 @@
       </p:sp>
       <p:sp>
         <p:nvSpPr>
-          <p:cNvPr id="7" name="TextBox 6"/>
+          <p:cNvPr id="10" name="TextBox 9"/>
           <p:cNvSpPr txBox="1"/>
           <p:nvPr/>
         </p:nvSpPr>
@@ -5484,7 +6053,7 @@
       </p:sp>
       <p:sp>
         <p:nvSpPr>
-          <p:cNvPr id="8" name="TextBox 7"/>
+          <p:cNvPr id="11" name="TextBox 10"/>
           <p:cNvSpPr txBox="1"/>
           <p:nvPr/>
         </p:nvSpPr>
@@ -5519,13 +6088,13 @@
       </p:sp>
       <p:sp>
         <p:nvSpPr>
-          <p:cNvPr id="9" name="TextBox 8"/>
+          <p:cNvPr id="12" name="TextBox 11"/>
           <p:cNvSpPr txBox="1"/>
           <p:nvPr/>
         </p:nvSpPr>
         <p:spPr>
           <a:xfrm>
-            <a:off x="8229600" y="6217920"/>
+            <a:off x="8229600" y="6172200"/>
             <a:ext cx="3566160" cy="365760"/>
           </a:xfrm>
           <a:prstGeom prst="rect">
@@ -5541,13 +6110,13 @@
           <a:p>
             <a:pPr algn="l"/>
             <a:r>
-              <a:rPr sz="1100" b="0" i="0">
+              <a:rPr sz="1400" b="1" i="0">
                 <a:solidFill>
                   <a:srgbClr val="2F4B4A"/>
                 </a:solidFill>
                 <a:latin typeface="Calibri"/>
               </a:rPr>
-              <a:t>Ecosistemas Digitales · Fotografías</a:t>
+              <a:t>Daniel Manzano</a:t>
             </a:r>
           </a:p>
         </p:txBody>
@@ -5557,6 +6126,95 @@
   <p:clrMapOvr>
     <a:masterClrMapping/>
   </p:clrMapOvr>
+  <p:transition spd="med">
+    <p:fade/>
+  </p:transition>
+  <p:timing>
+    <p:tnLst>
+      <p:par>
+        <p:cTn id="1" dur="indefinite" restart="never" nodeType="tmRoot">
+          <p:childTnLst>
+            <p:seq concurrent="1" nextAc="seek">
+              <p:cTn id="2" dur="indefinite" nodeType="mainSeq">
+                <p:childTnLst>
+                  <p:par>
+                    <p:cTn id="3" fill="hold">
+                      <p:stCondLst>
+                        <p:cond delay="indefinite"/>
+                        <p:cond evt="onBegin" delay="0">
+                          <p:tn val="2"/>
+                        </p:cond>
+                      </p:stCondLst>
+                      <p:childTnLst>
+                        <p:par>
+                          <p:cTn id="4" fill="hold">
+                            <p:stCondLst>
+                              <p:cond delay="0"/>
+                            </p:stCondLst>
+                            <p:childTnLst>
+                              <p:par>
+                                <p:cTn id="5" presetID="10" presetClass="entr" presetSubtype="0" fill="hold" nodeType="afterEffect">
+                                  <p:stCondLst>
+                                    <p:cond delay="0"/>
+                                  </p:stCondLst>
+                                  <p:childTnLst>
+                                    <p:set>
+                                      <p:cBhvr>
+                                        <p:cTn id="6" dur="1" fill="hold">
+                                          <p:stCondLst>
+                                            <p:cond delay="0"/>
+                                          </p:stCondLst>
+                                        </p:cTn>
+                                        <p:tgtEl>
+                                          <p:spTgt spid="3"/>
+                                        </p:tgtEl>
+                                        <p:attrNameLst>
+                                          <p:attrName>style.visibility</p:attrName>
+                                        </p:attrNameLst>
+                                      </p:cBhvr>
+                                      <p:to>
+                                        <p:strVal val="visible"/>
+                                      </p:to>
+                                    </p:set>
+                                    <p:animEffect transition="in" filter="fade">
+                                      <p:cBhvr>
+                                        <p:cTn id="7" dur="1200"/>
+                                        <p:tgtEl>
+                                          <p:spTgt spid="3"/>
+                                        </p:tgtEl>
+                                      </p:cBhvr>
+                                    </p:animEffect>
+                                  </p:childTnLst>
+                                </p:cTn>
+                              </p:par>
+                            </p:childTnLst>
+                          </p:cTn>
+                        </p:par>
+                      </p:childTnLst>
+                    </p:cTn>
+                  </p:par>
+                </p:childTnLst>
+              </p:cTn>
+              <p:prevCondLst>
+                <p:cond evt="onPrev" delay="0">
+                  <p:tgtEl>
+                    <p:sldTgt/>
+                  </p:tgtEl>
+                </p:cond>
+              </p:prevCondLst>
+              <p:nextCondLst>
+                <p:cond evt="onNext" delay="0">
+                  <p:tgtEl>
+                    <p:sldTgt/>
+                  </p:tgtEl>
+                </p:cond>
+              </p:nextCondLst>
+            </p:seq>
+          </p:childTnLst>
+        </p:cTn>
+      </p:par>
+    </p:tnLst>
+  </p:timing>
 </p:sld>
 </file>
 
@@ -5658,8 +6316,8 @@
         </p:nvSpPr>
         <p:spPr>
           <a:xfrm>
-            <a:off x="640080" y="5715000"/>
-            <a:ext cx="7132320" cy="365760"/>
+            <a:off x="640080" y="5669280"/>
+            <a:ext cx="7132320" cy="640080"/>
           </a:xfrm>
           <a:prstGeom prst="rect">
             <a:avLst/>
@@ -5680,14 +6338,14 @@
                 </a:solidFill>
                 <a:latin typeface="Calibri"/>
               </a:rPr>
-              <a:t>Configuración de cámara: ISO ___  ·  Apertura f/___  ·  Velocidad 1/___ s</a:t>
-            </a:r>
-          </a:p>
-        </p:txBody>
-      </p:sp>
-      <p:sp>
-        <p:nvSpPr>
-          <p:cNvPr id="5" name="TextBox 4"/>
+              <a:t>Configuración: ISO 200–400  ·  Velocidad 1/60 s  ·  Apertura según la luz (luz de sol)</a:t>
+            </a:r>
+          </a:p>
+        </p:txBody>
+      </p:sp>
+      <p:sp>
+        <p:nvSpPr>
+          <p:cNvPr id="8" name="TextBox 7"/>
           <p:cNvSpPr txBox="1"/>
           <p:nvPr/>
         </p:nvSpPr>
@@ -5722,7 +6380,7 @@
       </p:sp>
       <p:sp>
         <p:nvSpPr>
-          <p:cNvPr id="6" name="Rectangle 5"/>
+          <p:cNvPr id="9" name="Rectangle 8"/>
           <p:cNvSpPr/>
           <p:nvPr/>
         </p:nvSpPr>
@@ -5765,7 +6423,7 @@
       </p:sp>
       <p:sp>
         <p:nvSpPr>
-          <p:cNvPr id="7" name="TextBox 6"/>
+          <p:cNvPr id="10" name="TextBox 9"/>
           <p:cNvSpPr txBox="1"/>
           <p:nvPr/>
         </p:nvSpPr>
@@ -5800,7 +6458,7 @@
       </p:sp>
       <p:sp>
         <p:nvSpPr>
-          <p:cNvPr id="8" name="TextBox 7"/>
+          <p:cNvPr id="11" name="TextBox 10"/>
           <p:cNvSpPr txBox="1"/>
           <p:nvPr/>
         </p:nvSpPr>
@@ -5835,13 +6493,13 @@
       </p:sp>
       <p:sp>
         <p:nvSpPr>
-          <p:cNvPr id="9" name="TextBox 8"/>
+          <p:cNvPr id="12" name="TextBox 11"/>
           <p:cNvSpPr txBox="1"/>
           <p:nvPr/>
         </p:nvSpPr>
         <p:spPr>
           <a:xfrm>
-            <a:off x="8229600" y="6217920"/>
+            <a:off x="8229600" y="6172200"/>
             <a:ext cx="3566160" cy="365760"/>
           </a:xfrm>
           <a:prstGeom prst="rect">
@@ -5857,13 +6515,13 @@
           <a:p>
             <a:pPr algn="l"/>
             <a:r>
-              <a:rPr sz="1100" b="0" i="0">
+              <a:rPr sz="1400" b="1" i="0">
                 <a:solidFill>
                   <a:srgbClr val="2F4B4A"/>
                 </a:solidFill>
                 <a:latin typeface="Calibri"/>
               </a:rPr>
-              <a:t>Ecosistemas Digitales · Fotografías</a:t>
+              <a:t>Daniel Manzano</a:t>
             </a:r>
           </a:p>
         </p:txBody>
@@ -5873,6 +6531,95 @@
   <p:clrMapOvr>
     <a:masterClrMapping/>
   </p:clrMapOvr>
+  <p:transition spd="med">
+    <p:fade/>
+  </p:transition>
+  <p:timing>
+    <p:tnLst>
+      <p:par>
+        <p:cTn id="1" dur="indefinite" restart="never" nodeType="tmRoot">
+          <p:childTnLst>
+            <p:seq concurrent="1" nextAc="seek">
+              <p:cTn id="2" dur="indefinite" nodeType="mainSeq">
+                <p:childTnLst>
+                  <p:par>
+                    <p:cTn id="3" fill="hold">
+                      <p:stCondLst>
+                        <p:cond delay="indefinite"/>
+                        <p:cond evt="onBegin" delay="0">
+                          <p:tn val="2"/>
+                        </p:cond>
+                      </p:stCondLst>
+                      <p:childTnLst>
+                        <p:par>
+                          <p:cTn id="4" fill="hold">
+                            <p:stCondLst>
+                              <p:cond delay="0"/>
+                            </p:stCondLst>
+                            <p:childTnLst>
+                              <p:par>
+                                <p:cTn id="5" presetID="10" presetClass="entr" presetSubtype="0" fill="hold" nodeType="afterEffect">
+                                  <p:stCondLst>
+                                    <p:cond delay="0"/>
+                                  </p:stCondLst>
+                                  <p:childTnLst>
+                                    <p:set>
+                                      <p:cBhvr>
+                                        <p:cTn id="6" dur="1" fill="hold">
+                                          <p:stCondLst>
+                                            <p:cond delay="0"/>
+                                          </p:stCondLst>
+                                        </p:cTn>
+                                        <p:tgtEl>
+                                          <p:spTgt spid="3"/>
+                                        </p:tgtEl>
+                                        <p:attrNameLst>
+                                          <p:attrName>style.visibility</p:attrName>
+                                        </p:attrNameLst>
+                                      </p:cBhvr>
+                                      <p:to>
+                                        <p:strVal val="visible"/>
+                                      </p:to>
+                                    </p:set>
+                                    <p:animEffect transition="in" filter="fade">
+                                      <p:cBhvr>
+                                        <p:cTn id="7" dur="1200"/>
+                                        <p:tgtEl>
+                                          <p:spTgt spid="3"/>
+                                        </p:tgtEl>
+                                      </p:cBhvr>
+                                    </p:animEffect>
+                                  </p:childTnLst>
+                                </p:cTn>
+                              </p:par>
+                            </p:childTnLst>
+                          </p:cTn>
+                        </p:par>
+                      </p:childTnLst>
+                    </p:cTn>
+                  </p:par>
+                </p:childTnLst>
+              </p:cTn>
+              <p:prevCondLst>
+                <p:cond evt="onPrev" delay="0">
+                  <p:tgtEl>
+                    <p:sldTgt/>
+                  </p:tgtEl>
+                </p:cond>
+              </p:prevCondLst>
+              <p:nextCondLst>
+                <p:cond evt="onNext" delay="0">
+                  <p:tgtEl>
+                    <p:sldTgt/>
+                  </p:tgtEl>
+                </p:cond>
+              </p:nextCondLst>
+            </p:seq>
+          </p:childTnLst>
+        </p:cTn>
+      </p:par>
+    </p:tnLst>
+  </p:timing>
 </p:sld>
 </file>
 
@@ -5974,8 +6721,8 @@
         </p:nvSpPr>
         <p:spPr>
           <a:xfrm>
-            <a:off x="640080" y="5715000"/>
-            <a:ext cx="7132320" cy="365760"/>
+            <a:off x="640080" y="5669280"/>
+            <a:ext cx="7132320" cy="640080"/>
           </a:xfrm>
           <a:prstGeom prst="rect">
             <a:avLst/>
@@ -5996,14 +6743,14 @@
                 </a:solidFill>
                 <a:latin typeface="Calibri"/>
               </a:rPr>
-              <a:t>Configuración de cámara: ISO ___  ·  Apertura f/___  ·  Velocidad 1/___ s</a:t>
-            </a:r>
-          </a:p>
-        </p:txBody>
-      </p:sp>
-      <p:sp>
-        <p:nvSpPr>
-          <p:cNvPr id="5" name="TextBox 4"/>
+              <a:t>Configuración: ISO 200–400  ·  Velocidad 1/60 s  ·  Apertura según la luz (interior, poca luz)</a:t>
+            </a:r>
+          </a:p>
+        </p:txBody>
+      </p:sp>
+      <p:sp>
+        <p:nvSpPr>
+          <p:cNvPr id="8" name="TextBox 7"/>
           <p:cNvSpPr txBox="1"/>
           <p:nvPr/>
         </p:nvSpPr>
@@ -6038,7 +6785,7 @@
       </p:sp>
       <p:sp>
         <p:nvSpPr>
-          <p:cNvPr id="6" name="Rectangle 5"/>
+          <p:cNvPr id="9" name="Rectangle 8"/>
           <p:cNvSpPr/>
           <p:nvPr/>
         </p:nvSpPr>
@@ -6081,7 +6828,7 @@
       </p:sp>
       <p:sp>
         <p:nvSpPr>
-          <p:cNvPr id="7" name="TextBox 6"/>
+          <p:cNvPr id="10" name="TextBox 9"/>
           <p:cNvSpPr txBox="1"/>
           <p:nvPr/>
         </p:nvSpPr>
@@ -6116,7 +6863,7 @@
       </p:sp>
       <p:sp>
         <p:nvSpPr>
-          <p:cNvPr id="8" name="TextBox 7"/>
+          <p:cNvPr id="11" name="TextBox 10"/>
           <p:cNvSpPr txBox="1"/>
           <p:nvPr/>
         </p:nvSpPr>
@@ -6151,13 +6898,13 @@
       </p:sp>
       <p:sp>
         <p:nvSpPr>
-          <p:cNvPr id="9" name="TextBox 8"/>
+          <p:cNvPr id="12" name="TextBox 11"/>
           <p:cNvSpPr txBox="1"/>
           <p:nvPr/>
         </p:nvSpPr>
         <p:spPr>
           <a:xfrm>
-            <a:off x="8229600" y="6217920"/>
+            <a:off x="8229600" y="6172200"/>
             <a:ext cx="3566160" cy="365760"/>
           </a:xfrm>
           <a:prstGeom prst="rect">
@@ -6173,13 +6920,13 @@
           <a:p>
             <a:pPr algn="l"/>
             <a:r>
-              <a:rPr sz="1100" b="0" i="0">
+              <a:rPr sz="1400" b="1" i="0">
                 <a:solidFill>
                   <a:srgbClr val="2F4B4A"/>
                 </a:solidFill>
                 <a:latin typeface="Calibri"/>
               </a:rPr>
-              <a:t>Ecosistemas Digitales · Fotografías</a:t>
+              <a:t>Daniel Manzano</a:t>
             </a:r>
           </a:p>
         </p:txBody>
@@ -6189,6 +6936,95 @@
   <p:clrMapOvr>
     <a:masterClrMapping/>
   </p:clrMapOvr>
+  <p:transition spd="med">
+    <p:fade/>
+  </p:transition>
+  <p:timing>
+    <p:tnLst>
+      <p:par>
+        <p:cTn id="1" dur="indefinite" restart="never" nodeType="tmRoot">
+          <p:childTnLst>
+            <p:seq concurrent="1" nextAc="seek">
+              <p:cTn id="2" dur="indefinite" nodeType="mainSeq">
+                <p:childTnLst>
+                  <p:par>
+                    <p:cTn id="3" fill="hold">
+                      <p:stCondLst>
+                        <p:cond delay="indefinite"/>
+                        <p:cond evt="onBegin" delay="0">
+                          <p:tn val="2"/>
+                        </p:cond>
+                      </p:stCondLst>
+                      <p:childTnLst>
+                        <p:par>
+                          <p:cTn id="4" fill="hold">
+                            <p:stCondLst>
+                              <p:cond delay="0"/>
+                            </p:stCondLst>
+                            <p:childTnLst>
+                              <p:par>
+                                <p:cTn id="5" presetID="10" presetClass="entr" presetSubtype="0" fill="hold" nodeType="afterEffect">
+                                  <p:stCondLst>
+                                    <p:cond delay="0"/>
+                                  </p:stCondLst>
+                                  <p:childTnLst>
+                                    <p:set>
+                                      <p:cBhvr>
+                                        <p:cTn id="6" dur="1" fill="hold">
+                                          <p:stCondLst>
+                                            <p:cond delay="0"/>
+                                          </p:stCondLst>
+                                        </p:cTn>
+                                        <p:tgtEl>
+                                          <p:spTgt spid="3"/>
+                                        </p:tgtEl>
+                                        <p:attrNameLst>
+                                          <p:attrName>style.visibility</p:attrName>
+                                        </p:attrNameLst>
+                                      </p:cBhvr>
+                                      <p:to>
+                                        <p:strVal val="visible"/>
+                                      </p:to>
+                                    </p:set>
+                                    <p:animEffect transition="in" filter="fade">
+                                      <p:cBhvr>
+                                        <p:cTn id="7" dur="1200"/>
+                                        <p:tgtEl>
+                                          <p:spTgt spid="3"/>
+                                        </p:tgtEl>
+                                      </p:cBhvr>
+                                    </p:animEffect>
+                                  </p:childTnLst>
+                                </p:cTn>
+                              </p:par>
+                            </p:childTnLst>
+                          </p:cTn>
+                        </p:par>
+                      </p:childTnLst>
+                    </p:cTn>
+                  </p:par>
+                </p:childTnLst>
+              </p:cTn>
+              <p:prevCondLst>
+                <p:cond evt="onPrev" delay="0">
+                  <p:tgtEl>
+                    <p:sldTgt/>
+                  </p:tgtEl>
+                </p:cond>
+              </p:prevCondLst>
+              <p:nextCondLst>
+                <p:cond evt="onNext" delay="0">
+                  <p:tgtEl>
+                    <p:sldTgt/>
+                  </p:tgtEl>
+                </p:cond>
+              </p:nextCondLst>
+            </p:seq>
+          </p:childTnLst>
+        </p:cTn>
+      </p:par>
+    </p:tnLst>
+  </p:timing>
 </p:sld>
 </file>
 
@@ -6290,8 +7126,8 @@
         </p:nvSpPr>
         <p:spPr>
           <a:xfrm>
-            <a:off x="640080" y="5715000"/>
-            <a:ext cx="7132320" cy="365760"/>
+            <a:off x="640080" y="5669280"/>
+            <a:ext cx="7132320" cy="640080"/>
           </a:xfrm>
           <a:prstGeom prst="rect">
             <a:avLst/>
@@ -6312,14 +7148,14 @@
                 </a:solidFill>
                 <a:latin typeface="Calibri"/>
               </a:rPr>
-              <a:t>Configuración de cámara: ISO ___  ·  Apertura f/___  ·  Velocidad 1/___ s</a:t>
-            </a:r>
-          </a:p>
-        </p:txBody>
-      </p:sp>
-      <p:sp>
-        <p:nvSpPr>
-          <p:cNvPr id="5" name="TextBox 4"/>
+              <a:t>Configuración: ISO 200–400  ·  Velocidad 1/60 s  ·  Apertura según la luz (sombra)</a:t>
+            </a:r>
+          </a:p>
+        </p:txBody>
+      </p:sp>
+      <p:sp>
+        <p:nvSpPr>
+          <p:cNvPr id="8" name="TextBox 7"/>
           <p:cNvSpPr txBox="1"/>
           <p:nvPr/>
         </p:nvSpPr>
@@ -6354,7 +7190,7 @@
       </p:sp>
       <p:sp>
         <p:nvSpPr>
-          <p:cNvPr id="6" name="Rectangle 5"/>
+          <p:cNvPr id="9" name="Rectangle 8"/>
           <p:cNvSpPr/>
           <p:nvPr/>
         </p:nvSpPr>
@@ -6397,7 +7233,7 @@
       </p:sp>
       <p:sp>
         <p:nvSpPr>
-          <p:cNvPr id="7" name="TextBox 6"/>
+          <p:cNvPr id="10" name="TextBox 9"/>
           <p:cNvSpPr txBox="1"/>
           <p:nvPr/>
         </p:nvSpPr>
@@ -6432,7 +7268,7 @@
       </p:sp>
       <p:sp>
         <p:nvSpPr>
-          <p:cNvPr id="8" name="TextBox 7"/>
+          <p:cNvPr id="11" name="TextBox 10"/>
           <p:cNvSpPr txBox="1"/>
           <p:nvPr/>
         </p:nvSpPr>
@@ -6467,13 +7303,13 @@
       </p:sp>
       <p:sp>
         <p:nvSpPr>
-          <p:cNvPr id="9" name="TextBox 8"/>
+          <p:cNvPr id="12" name="TextBox 11"/>
           <p:cNvSpPr txBox="1"/>
           <p:nvPr/>
         </p:nvSpPr>
         <p:spPr>
           <a:xfrm>
-            <a:off x="8229600" y="6217920"/>
+            <a:off x="8229600" y="6172200"/>
             <a:ext cx="3566160" cy="365760"/>
           </a:xfrm>
           <a:prstGeom prst="rect">
@@ -6489,13 +7325,13 @@
           <a:p>
             <a:pPr algn="l"/>
             <a:r>
-              <a:rPr sz="1100" b="0" i="0">
+              <a:rPr sz="1400" b="1" i="0">
                 <a:solidFill>
                   <a:srgbClr val="2F4B4A"/>
                 </a:solidFill>
                 <a:latin typeface="Calibri"/>
               </a:rPr>
-              <a:t>Ecosistemas Digitales · Fotografías</a:t>
+              <a:t>Daniel Manzano</a:t>
             </a:r>
           </a:p>
         </p:txBody>
@@ -6505,6 +7341,95 @@
   <p:clrMapOvr>
     <a:masterClrMapping/>
   </p:clrMapOvr>
+  <p:transition spd="med">
+    <p:fade/>
+  </p:transition>
+  <p:timing>
+    <p:tnLst>
+      <p:par>
+        <p:cTn id="1" dur="indefinite" restart="never" nodeType="tmRoot">
+          <p:childTnLst>
+            <p:seq concurrent="1" nextAc="seek">
+              <p:cTn id="2" dur="indefinite" nodeType="mainSeq">
+                <p:childTnLst>
+                  <p:par>
+                    <p:cTn id="3" fill="hold">
+                      <p:stCondLst>
+                        <p:cond delay="indefinite"/>
+                        <p:cond evt="onBegin" delay="0">
+                          <p:tn val="2"/>
+                        </p:cond>
+                      </p:stCondLst>
+                      <p:childTnLst>
+                        <p:par>
+                          <p:cTn id="4" fill="hold">
+                            <p:stCondLst>
+                              <p:cond delay="0"/>
+                            </p:stCondLst>
+                            <p:childTnLst>
+                              <p:par>
+                                <p:cTn id="5" presetID="10" presetClass="entr" presetSubtype="0" fill="hold" nodeType="afterEffect">
+                                  <p:stCondLst>
+                                    <p:cond delay="0"/>
+                                  </p:stCondLst>
+                                  <p:childTnLst>
+                                    <p:set>
+                                      <p:cBhvr>
+                                        <p:cTn id="6" dur="1" fill="hold">
+                                          <p:stCondLst>
+                                            <p:cond delay="0"/>
+                                          </p:stCondLst>
+                                        </p:cTn>
+                                        <p:tgtEl>
+                                          <p:spTgt spid="3"/>
+                                        </p:tgtEl>
+                                        <p:attrNameLst>
+                                          <p:attrName>style.visibility</p:attrName>
+                                        </p:attrNameLst>
+                                      </p:cBhvr>
+                                      <p:to>
+                                        <p:strVal val="visible"/>
+                                      </p:to>
+                                    </p:set>
+                                    <p:animEffect transition="in" filter="fade">
+                                      <p:cBhvr>
+                                        <p:cTn id="7" dur="1200"/>
+                                        <p:tgtEl>
+                                          <p:spTgt spid="3"/>
+                                        </p:tgtEl>
+                                      </p:cBhvr>
+                                    </p:animEffect>
+                                  </p:childTnLst>
+                                </p:cTn>
+                              </p:par>
+                            </p:childTnLst>
+                          </p:cTn>
+                        </p:par>
+                      </p:childTnLst>
+                    </p:cTn>
+                  </p:par>
+                </p:childTnLst>
+              </p:cTn>
+              <p:prevCondLst>
+                <p:cond evt="onPrev" delay="0">
+                  <p:tgtEl>
+                    <p:sldTgt/>
+                  </p:tgtEl>
+                </p:cond>
+              </p:prevCondLst>
+              <p:nextCondLst>
+                <p:cond evt="onNext" delay="0">
+                  <p:tgtEl>
+                    <p:sldTgt/>
+                  </p:tgtEl>
+                </p:cond>
+              </p:nextCondLst>
+            </p:seq>
+          </p:childTnLst>
+        </p:cTn>
+      </p:par>
+    </p:tnLst>
+  </p:timing>
 </p:sld>
 </file>
 

</xml_diff>

<commit_message>
Agregar enfoque automático a la configuración de cámara
Co-Authored-By: Claude Sonnet 5.5 <noreply@anthropic.com>
Claude-Session: https://claude.ai/code/session_01Y5F8QoKRcD6in8KfcG1na8
</commit_message>
<xml_diff>
--- a/Ecosistemas_Digitales_Fotografias.pptx
+++ b/Ecosistemas_Digitales_Fotografias.pptx
@@ -3503,7 +3503,8 @@
                 </a:solidFill>
                 <a:latin typeface="Calibri"/>
               </a:rPr>
-              <a:t>Configuración: ISO 200–400  ·  Velocidad 1/60 s  ·  Apertura según la luz (sombra)</a:t>
+              <a:t>Configuración: ISO 200–400  ·  Velocidad 1/60 s  ·  Apertura según la luz (sombra)
+Enfoque: automático (botón presionado a medias)</a:t>
             </a:r>
           </a:p>
         </p:txBody>
@@ -3908,7 +3909,8 @@
                 </a:solidFill>
                 <a:latin typeface="Calibri"/>
               </a:rPr>
-              <a:t>Configuración: ISO 200–400  ·  Velocidad 1/60 s  ·  Apertura según la luz (luz de sol)</a:t>
+              <a:t>Configuración: ISO 200–400  ·  Velocidad 1/60 s  ·  Apertura según la luz (luz de sol)
+Enfoque: automático (botón presionado a medias)</a:t>
             </a:r>
           </a:p>
         </p:txBody>
@@ -4313,7 +4315,8 @@
                 </a:solidFill>
                 <a:latin typeface="Calibri"/>
               </a:rPr>
-              <a:t>Configuración: ISO 200–400  ·  Velocidad 1/60 s  ·  Apertura según la luz (luz de sol)</a:t>
+              <a:t>Configuración: ISO 200–400  ·  Velocidad 1/60 s  ·  Apertura según la luz (luz de sol)
+Enfoque: automático (botón presionado a medias)</a:t>
             </a:r>
           </a:p>
         </p:txBody>
@@ -4718,7 +4721,8 @@
                 </a:solidFill>
                 <a:latin typeface="Calibri"/>
               </a:rPr>
-              <a:t>Configuración: ISO 200–400  ·  Velocidad 1/60 s  ·  Apertura según la luz (luz de sol)</a:t>
+              <a:t>Configuración: ISO 200–400  ·  Velocidad 1/60 s  ·  Apertura según la luz (luz de sol)
+Enfoque: automático (botón presionado a medias)</a:t>
             </a:r>
           </a:p>
         </p:txBody>
@@ -5123,7 +5127,8 @@
                 </a:solidFill>
                 <a:latin typeface="Calibri"/>
               </a:rPr>
-              <a:t>Configuración: ISO 200–400  ·  Velocidad 1/60 s  ·  Apertura según la luz (luz de sol)</a:t>
+              <a:t>Configuración: ISO 200–400  ·  Velocidad 1/60 s  ·  Apertura según la luz (luz de sol)
+Enfoque: automático (botón presionado a medias)</a:t>
             </a:r>
           </a:p>
         </p:txBody>
@@ -5528,7 +5533,8 @@
                 </a:solidFill>
                 <a:latin typeface="Calibri"/>
               </a:rPr>
-              <a:t>Configuración: ISO 200–400  ·  Velocidad 1/60 s  ·  Apertura según la luz (luz suave de pasillo)</a:t>
+              <a:t>Configuración: ISO 200–400  ·  Velocidad 1/60 s  ·  Apertura según la luz (luz suave de pasillo)
+Enfoque: automático (botón presionado a medias)</a:t>
             </a:r>
           </a:p>
         </p:txBody>
@@ -5933,7 +5939,8 @@
                 </a:solidFill>
                 <a:latin typeface="Calibri"/>
               </a:rPr>
-              <a:t>Configuración: ISO 200–400  ·  Velocidad 1/60 s  ·  Apertura según la luz (luz de sol)</a:t>
+              <a:t>Configuración: ISO 200–400  ·  Velocidad 1/60 s  ·  Apertura según la luz (luz de sol)
+Enfoque: automático (botón presionado a medias)</a:t>
             </a:r>
           </a:p>
         </p:txBody>
@@ -6338,7 +6345,8 @@
                 </a:solidFill>
                 <a:latin typeface="Calibri"/>
               </a:rPr>
-              <a:t>Configuración: ISO 200–400  ·  Velocidad 1/60 s  ·  Apertura según la luz (luz de sol)</a:t>
+              <a:t>Configuración: ISO 200–400  ·  Velocidad 1/60 s  ·  Apertura según la luz (luz de sol)
+Enfoque: automático (botón presionado a medias)</a:t>
             </a:r>
           </a:p>
         </p:txBody>
@@ -6743,7 +6751,8 @@
                 </a:solidFill>
                 <a:latin typeface="Calibri"/>
               </a:rPr>
-              <a:t>Configuración: ISO 200–400  ·  Velocidad 1/60 s  ·  Apertura según la luz (interior, poca luz)</a:t>
+              <a:t>Configuración: ISO 200–400  ·  Velocidad 1/60 s  ·  Apertura según la luz (interior, poca luz)
+Enfoque: automático (botón presionado a medias)</a:t>
             </a:r>
           </a:p>
         </p:txBody>
@@ -7148,7 +7157,8 @@
                 </a:solidFill>
                 <a:latin typeface="Calibri"/>
               </a:rPr>
-              <a:t>Configuración: ISO 200–400  ·  Velocidad 1/60 s  ·  Apertura según la luz (sombra)</a:t>
+              <a:t>Configuración: ISO 200–400  ·  Velocidad 1/60 s  ·  Apertura según la luz (sombra)
+Enfoque: automático (botón presionado a medias)</a:t>
             </a:r>
           </a:p>
         </p:txBody>

</xml_diff>